<commit_message>
Actually apply the personal-name removal (previous commit only staged the rename)
The prior commit's `git add` silently failed on a stale pathspec and only the
file rename got committed; the text edits were never staged. This commit is
the real content fix: drops informal references and author-surname citations
that identified the advisor or the parallel workstream's collaborator, across
docs, the slide deck, code comments, and the articles spreadsheet.
</commit_message>
<xml_diff>
--- a/slides/DELTA_progress.pptx
+++ b/slides/DELTA_progress.pptx
@@ -3244,17 +3244,6 @@
                 </a:solidFill>
                 <a:latin typeface="Calibri"/>
               </a:rPr>
-              <a:t>Advisor: Mariella Dimiccoli</a:t>
-            </a:r>
-          </a:p>
-          <a:p>
-            <a:r>
-              <a:rPr sz="1300">
-                <a:solidFill>
-                  <a:srgbClr val="5B6470"/>
-                </a:solidFill>
-                <a:latin typeface="Calibri"/>
-              </a:rPr>
               <a:t>Base work: DELTA — Dense Long-Term Action Anticipation from Procedural Transcripts</a:t>
             </a:r>
           </a:p>
@@ -3758,7 +3747,7 @@
                           </a:solidFill>
                           <a:latin typeface="Calibri"/>
                         </a:rPr>
-                        <a:t>co-intern — the VLM aligner</a:t>
+                        <a:t>the VLM aligner</a:t>
                       </a:r>
                     </a:p>
                   </a:txBody>
@@ -4019,7 +4008,7 @@
                 </a:solidFill>
                 <a:latin typeface="Calibri"/>
               </a:rPr>
-              <a:t>CVA = the aligner (co-intern)   ·   MASRA = the language regulariser (Eliz)</a:t>
+              <a:t>CVA = the aligner   ·   MASRA = the language regulariser</a:t>
             </a:r>
           </a:p>
         </p:txBody>
@@ -4284,7 +4273,7 @@
                 </a:solidFill>
                 <a:latin typeface="Calibri"/>
               </a:rPr>
-              <a:t>Eliz → MASRA   ·   co-intern → CVA   ·   both VLM</a:t>
+              <a:t>MASRA track   ·   CVA track   ·   both VLM</a:t>
             </a:r>
           </a:p>
         </p:txBody>
@@ -4392,7 +4381,7 @@
                 </a:solidFill>
                 <a:latin typeface="Calibri"/>
               </a:rPr>
-              <a:t>▸ Co-intern → CVA:  build the VLM aligner — CTE encoder + CBD boundary-contrastive loss.</a:t>
+              <a:t>▸ CVA track:  build the VLM aligner — CTE encoder + CBD boundary-contrastive loss.</a:t>
             </a:r>
           </a:p>
           <a:p>
@@ -6276,7 +6265,7 @@
                 </a:solidFill>
                 <a:latin typeface="Calibri"/>
               </a:rPr>
-              <a:t>InternVideo2 similarity  +  MASRA regulariser (Eliz)  +  CVA aligner (co-intern)  →  DELTA</a:t>
+              <a:t>InternVideo2 similarity  +  MASRA regulariser  +  CVA aligner  →  DELTA</a:t>
             </a:r>
           </a:p>
         </p:txBody>
@@ -6390,7 +6379,7 @@
                 </a:solidFill>
                 <a:latin typeface="Calibri"/>
               </a:rPr>
-              <a:t>▸ + CVA (co-intern):  CTE-style encoder on the VLM features; CBD boundary-contrastive loss on the aligned boundary frames.</a:t>
+              <a:t>▸ + CVA:  CTE-style encoder on the VLM features; CBD boundary-contrastive loss on the aligned boundary frames.</a:t>
             </a:r>
           </a:p>
           <a:p>
@@ -6615,7 +6604,7 @@
                           </a:solidFill>
                           <a:latin typeface="Calibri"/>
                         </a:rPr>
-                        <a:t>Eliz — MASRA</a:t>
+                        <a:t>MASRA track</a:t>
                       </a:r>
                     </a:p>
                   </a:txBody>
@@ -6637,7 +6626,7 @@
                           </a:solidFill>
                           <a:latin typeface="Calibri"/>
                         </a:rPr>
-                        <a:t>Co-intern — CVA</a:t>
+                        <a:t>CVA track</a:t>
                       </a:r>
                     </a:p>
                   </a:txBody>
@@ -7188,7 +7177,7 @@
                 </a:solidFill>
                 <a:latin typeface="Calibri"/>
               </a:rPr>
-              <a:t>▸ Workstream split:  Eliz → MASRA  ·  co-intern → CVA.  Both are VLM video-text alignment.</a:t>
+              <a:t>▸ Workstream split:  MASRA track  ·  CVA track.  Both are VLM video-text alignment.</a:t>
             </a:r>
           </a:p>
           <a:p>
@@ -8088,7 +8077,7 @@
                 </a:solidFill>
                 <a:latin typeface="Calibri"/>
               </a:rPr>
-              <a:t>– CVA (CVPR'26) — the aligner: hierarchical encoder + boundary-contrastive loss.  (co-intern)</a:t>
+              <a:t>– CVA (CVPR'26) — the aligner: hierarchical encoder + boundary-contrastive loss.</a:t>
             </a:r>
           </a:p>
           <a:p>

</xml_diff>

<commit_message>
Update the deck with measured results
The back half was still the pre-measurement plan (InternVideo2, "chase raw 50S
video", an M1-M7 schedule) with no numbers in it. Replaced with a results
section and refreshed the opening summary and takeaways.

New: the headline table (every method vs the naive-uniform floor), the
diagnostic evidence for why (0.94 frame similarity, 27% on the hard semantic
test, the self-confirmation trace), what the results do and don't imply, the
build/test status, and the asks -- GPU access with remote access confirmed
before the on-site weeks end, plus the direction call.

States plainly that 67 passing tests show the code is correct on synthetic
data, not that the method works.
</commit_message>
<xml_diff>
--- a/slides/DELTA_progress.pptx
+++ b/slides/DELTA_progress.pptx
@@ -4510,7 +4510,7 @@
                 </a:solidFill>
                 <a:latin typeface="Calibri"/>
               </a:rPr>
-              <a:t>what the analysis established</a:t>
+              <a:t>what the work so far establishes</a:t>
             </a:r>
           </a:p>
         </p:txBody>
@@ -4592,7 +4592,7 @@
                 </a:solidFill>
                 <a:latin typeface="Calibri"/>
               </a:rPr>
-              <a:t>▸ "Alignment through segmentation" (ATBA / HAL) is a trained classifier that 50Salads breaks — and the supervisor has ruled it out.</a:t>
+              <a:t>▸ The pipeline is implemented end to end and unit-tested; the approach is unproven.</a:t>
             </a:r>
           </a:p>
           <a:p>
@@ -4608,7 +4608,7 @@
                 </a:solidFill>
                 <a:latin typeface="Calibri"/>
               </a:rPr>
-              <a:t>▸ The move: replace the classifier posteriors with a frozen-VLM transcript×frame similarity, then an order-preserving alignment.</a:t>
+              <a:t>▸ Both paradigms lose to the no-evidence floor on 50Salads — VLM-direct AND classifier-based. The bottleneck is the evidence, not the algorithm.</a:t>
             </a:r>
           </a:p>
           <a:p>
@@ -4624,7 +4624,7 @@
                 </a:solidFill>
                 <a:latin typeface="Calibri"/>
               </a:rPr>
-              <a:t>▸ DELTA already has optimal-transport alignment (ASOT, --model_type wclot) — the VLM swap is ≈ one line in the cost matrix; CTC / CRF / LTA decoder / eval are all reused.</a:t>
+              <a:t>▸ DELTA already has optimal-transport alignment (ASOT, --model_type wclot), so our Y* drops into the existing decoder unchanged — CTC / CRF / duration head / eval all reused.</a:t>
             </a:r>
           </a:p>
           <a:p>
@@ -4640,7 +4640,7 @@
                 </a:solidFill>
                 <a:latin typeface="Calibri"/>
               </a:rPr>
-              <a:t>▸ CVA + MASRA (CVPR'26 / 2026) do VLM video-text alignment for grounding; we adapt them to transcript-supervised dense anticipation — which nobody has done.</a:t>
+              <a:t>▸ Ideas are drawn from OVTAS (similarity), HiERO-StepG (monotonic decode), CVA (boundary contrastive), MASRA (relational losses); the local boundary search is ours.</a:t>
             </a:r>
           </a:p>
           <a:p>
@@ -4656,7 +4656,7 @@
                 </a:solidFill>
                 <a:latin typeface="Calibri"/>
               </a:rPr>
-              <a:t>▸ HAL analysed and dropped; kept only as a baseline number.</a:t>
+              <a:t>▸ Next real test: video-level features (VideoLLaMA3) rather than frame-level — the one thing that directly addresses the measured failure.</a:t>
             </a:r>
           </a:p>
         </p:txBody>
@@ -5265,7 +5265,7 @@
                 </a:solidFill>
                 <a:latin typeface="Calibri"/>
               </a:rPr>
-              <a:t>FOR DISCUSSION</a:t>
+              <a:t>EVERYTHING MEASURED SO FAR</a:t>
             </a:r>
           </a:p>
           <a:p>
@@ -5276,7 +5276,7 @@
                 </a:solidFill>
                 <a:latin typeface="Calibri"/>
               </a:rPr>
-              <a:t>How we proceed with the TA</a:t>
+              <a:t>Results</a:t>
             </a:r>
           </a:p>
         </p:txBody>
@@ -5336,7 +5336,7 @@
                 </a:solidFill>
                 <a:latin typeface="Calibri"/>
               </a:rPr>
-              <a:t>Scope — 50Salads only</a:t>
+              <a:t>The headline — nothing beats a baseline that ignores the video</a:t>
             </a:r>
           </a:p>
           <a:p>
@@ -5347,7 +5347,7 @@
                 </a:solidFill>
                 <a:latin typeface="Calibri"/>
               </a:rPr>
-              <a:t>VLM-only · TA metrics → DLTA metrics · one dataset</a:t>
+              <a:t>50Salads split-1 test.  The floor uses NO visual information at all — anything below it means the visual evidence is hurting, not helping.</a:t>
             </a:r>
           </a:p>
         </p:txBody>
@@ -5395,125 +5395,664 @@
           </a:p>
         </p:txBody>
       </p:sp>
-      <p:sp>
-        <p:nvSpPr>
-          <p:cNvPr id="4" name="TextBox 3"/>
-          <p:cNvSpPr txBox="1"/>
+      <p:graphicFrame>
+        <p:nvGraphicFramePr>
+          <p:cNvPr id="4" name="Table 3"/>
+          <p:cNvGraphicFramePr>
+            <a:graphicFrameLocks noGrp="1"/>
+          </p:cNvGraphicFramePr>
           <p:nvPr/>
-        </p:nvSpPr>
-        <p:spPr>
-          <a:xfrm>
-            <a:off x="640080" y="1600200"/>
-            <a:ext cx="10972800" cy="4937760"/>
-          </a:xfrm>
-          <a:prstGeom prst="rect">
-            <a:avLst/>
-          </a:prstGeom>
-          <a:noFill/>
-        </p:spPr>
-        <p:txBody>
-          <a:bodyPr wrap="square">
-            <a:spAutoFit/>
-          </a:bodyPr>
-          <a:lstStyle/>
-          <a:p>
-            <a:pPr>
-              <a:spcAft>
-                <a:spcPts val="600"/>
-              </a:spcAft>
-            </a:pPr>
-            <a:r>
-              <a:rPr sz="1700" b="0">
-                <a:solidFill>
-                  <a:srgbClr val="22262B"/>
-                </a:solidFill>
-                <a:latin typeface="Calibri"/>
-              </a:rPr>
-              <a:t>▸ No Breakfast, no segmentation-based approach, no HAL workstream (kept as a baseline number).</a:t>
-            </a:r>
-          </a:p>
-          <a:p>
-            <a:pPr>
-              <a:spcAft>
-                <a:spcPts val="600"/>
-              </a:spcAft>
-            </a:pPr>
-            <a:r>
-              <a:rPr sz="1700" b="0">
-                <a:solidFill>
-                  <a:srgbClr val="22262B"/>
-                </a:solidFill>
-                <a:latin typeface="Calibri"/>
-              </a:rPr>
-              <a:t>▸ One dataset, evaluated two ways — TA metrics gate the DLTA metrics:</a:t>
-            </a:r>
-          </a:p>
-          <a:p>
-            <a:pPr lvl="1">
-              <a:spcAft>
-                <a:spcPts val="600"/>
-              </a:spcAft>
-            </a:pPr>
-            <a:r>
-              <a:rPr sz="1500">
-                <a:solidFill>
-                  <a:srgbClr val="5B6470"/>
-                </a:solidFill>
-                <a:latin typeface="Calibri"/>
-              </a:rPr>
-              <a:t>– TA metrics:  MoF / MoC / Edit / F1@{10,25,50} / median per-transition boundary offset — on Y* vs held-out GT.</a:t>
-            </a:r>
-          </a:p>
-          <a:p>
-            <a:pPr lvl="1">
-              <a:spcAft>
-                <a:spcPts val="600"/>
-              </a:spcAft>
-            </a:pPr>
-            <a:r>
-              <a:rPr sz="1500">
-                <a:solidFill>
-                  <a:srgbClr val="5B6470"/>
-                </a:solidFill>
-                <a:latin typeface="Calibri"/>
-              </a:rPr>
-              <a:t>– DLTA metrics:  Obs{20,30}% × Pred{10,20,30,50}% MoC — the DELTA anticipation grid.</a:t>
-            </a:r>
-          </a:p>
-          <a:p>
-            <a:pPr>
-              <a:spcAft>
-                <a:spcPts val="600"/>
-              </a:spcAft>
-            </a:pPr>
-            <a:r>
-              <a:rPr sz="1700" b="0">
-                <a:solidFill>
-                  <a:srgbClr val="22262B"/>
-                </a:solidFill>
-                <a:latin typeface="Calibri"/>
-              </a:rPr>
-              <a:t>▸ Method = frozen VLM (InternVideo2) transcript×frame similarity  →  MASRA-style regularisation (LRCA/ESTA)  →  order-preserving alignment (ASOT, already in DELTA)  →  Y*  →  DELTA decoder.</a:t>
-            </a:r>
-          </a:p>
-          <a:p>
-            <a:pPr>
-              <a:spcAft>
-                <a:spcPts val="600"/>
-              </a:spcAft>
-            </a:pPr>
-            <a:r>
-              <a:rPr sz="1700" b="0">
-                <a:solidFill>
-                  <a:srgbClr val="22262B"/>
-                </a:solidFill>
-                <a:latin typeface="Calibri"/>
-              </a:rPr>
-              <a:t>▸ Baselines:  naive-uniform 0.34 MoC  ·  ATBA-in-DELTA (--model_type atba)  ·  ASOT-in-DELTA (--model_type wclot)  ·  HAL number (from its paper).</a:t>
-            </a:r>
-          </a:p>
-        </p:txBody>
-      </p:sp>
+        </p:nvGraphicFramePr>
+        <p:xfrm>
+          <a:off x="548640" y="1645920"/>
+          <a:ext cx="10424160" cy="2560320"/>
+        </p:xfrm>
+        <a:graphic>
+          <a:graphicData uri="http://schemas.openxmlformats.org/drawingml/2006/table">
+            <a:tbl>
+              <a:tblPr firstRow="1" bandRow="1">
+                <a:tableStyleId>{5C22544A-7EE6-4342-B048-85BDC9FD1C3A}</a:tableStyleId>
+              </a:tblPr>
+              <a:tblGrid>
+                <a:gridCol w="6035040"/>
+                <a:gridCol w="1463040"/>
+                <a:gridCol w="1463040"/>
+                <a:gridCol w="1463040"/>
+              </a:tblGrid>
+              <a:tr h="365760">
+                <a:tc>
+                  <a:txBody>
+                    <a:bodyPr/>
+                    <a:lstStyle/>
+                    <a:p>
+                      <a:r>
+                        <a:rPr sz="1150" b="1">
+                          <a:solidFill>
+                            <a:srgbClr val="FFFFFF"/>
+                          </a:solidFill>
+                          <a:latin typeface="Calibri"/>
+                        </a:rPr>
+                        <a:t>Method</a:t>
+                      </a:r>
+                    </a:p>
+                  </a:txBody>
+                  <a:tcPr>
+                    <a:solidFill>
+                      <a:srgbClr val="1F3A5F"/>
+                    </a:solidFill>
+                  </a:tcPr>
+                </a:tc>
+                <a:tc>
+                  <a:txBody>
+                    <a:bodyPr/>
+                    <a:lstStyle/>
+                    <a:p>
+                      <a:r>
+                        <a:rPr sz="1150" b="1">
+                          <a:solidFill>
+                            <a:srgbClr val="FFFFFF"/>
+                          </a:solidFill>
+                          <a:latin typeface="Calibri"/>
+                        </a:rPr>
+                        <a:t>Uses video?</a:t>
+                      </a:r>
+                    </a:p>
+                  </a:txBody>
+                  <a:tcPr>
+                    <a:solidFill>
+                      <a:srgbClr val="1F3A5F"/>
+                    </a:solidFill>
+                  </a:tcPr>
+                </a:tc>
+                <a:tc>
+                  <a:txBody>
+                    <a:bodyPr/>
+                    <a:lstStyle/>
+                    <a:p>
+                      <a:r>
+                        <a:rPr sz="1150" b="1">
+                          <a:solidFill>
+                            <a:srgbClr val="FFFFFF"/>
+                          </a:solidFill>
+                          <a:latin typeface="Calibri"/>
+                        </a:rPr>
+                        <a:t>MoC</a:t>
+                      </a:r>
+                    </a:p>
+                  </a:txBody>
+                  <a:tcPr>
+                    <a:solidFill>
+                      <a:srgbClr val="1F3A5F"/>
+                    </a:solidFill>
+                  </a:tcPr>
+                </a:tc>
+                <a:tc>
+                  <a:txBody>
+                    <a:bodyPr/>
+                    <a:lstStyle/>
+                    <a:p>
+                      <a:r>
+                        <a:rPr sz="1150" b="1">
+                          <a:solidFill>
+                            <a:srgbClr val="FFFFFF"/>
+                          </a:solidFill>
+                          <a:latin typeface="Calibri"/>
+                        </a:rPr>
+                        <a:t>F1@50</a:t>
+                      </a:r>
+                    </a:p>
+                  </a:txBody>
+                  <a:tcPr>
+                    <a:solidFill>
+                      <a:srgbClr val="1F3A5F"/>
+                    </a:solidFill>
+                  </a:tcPr>
+                </a:tc>
+              </a:tr>
+              <a:tr h="365760">
+                <a:tc>
+                  <a:txBody>
+                    <a:bodyPr/>
+                    <a:lstStyle/>
+                    <a:p>
+                      <a:r>
+                        <a:rPr sz="1050">
+                          <a:solidFill>
+                            <a:srgbClr val="22262B"/>
+                          </a:solidFill>
+                          <a:latin typeface="Calibri"/>
+                        </a:rPr>
+                        <a:t>naive-uniform  (split into N equal blocks, transcript order)</a:t>
+                      </a:r>
+                    </a:p>
+                  </a:txBody>
+                  <a:tcPr>
+                    <a:solidFill>
+                      <a:srgbClr val="FFFFFF"/>
+                    </a:solidFill>
+                  </a:tcPr>
+                </a:tc>
+                <a:tc>
+                  <a:txBody>
+                    <a:bodyPr/>
+                    <a:lstStyle/>
+                    <a:p>
+                      <a:r>
+                        <a:rPr sz="1050">
+                          <a:solidFill>
+                            <a:srgbClr val="22262B"/>
+                          </a:solidFill>
+                          <a:latin typeface="Calibri"/>
+                        </a:rPr>
+                        <a:t>no</a:t>
+                      </a:r>
+                    </a:p>
+                  </a:txBody>
+                  <a:tcPr>
+                    <a:solidFill>
+                      <a:srgbClr val="FFFFFF"/>
+                    </a:solidFill>
+                  </a:tcPr>
+                </a:tc>
+                <a:tc>
+                  <a:txBody>
+                    <a:bodyPr/>
+                    <a:lstStyle/>
+                    <a:p>
+                      <a:r>
+                        <a:rPr sz="1050">
+                          <a:solidFill>
+                            <a:srgbClr val="22262B"/>
+                          </a:solidFill>
+                          <a:latin typeface="Calibri"/>
+                        </a:rPr>
+                        <a:t>0.366</a:t>
+                      </a:r>
+                    </a:p>
+                  </a:txBody>
+                  <a:tcPr>
+                    <a:solidFill>
+                      <a:srgbClr val="FFFFFF"/>
+                    </a:solidFill>
+                  </a:tcPr>
+                </a:tc>
+                <a:tc>
+                  <a:txBody>
+                    <a:bodyPr/>
+                    <a:lstStyle/>
+                    <a:p>
+                      <a:r>
+                        <a:rPr sz="1050">
+                          <a:solidFill>
+                            <a:srgbClr val="22262B"/>
+                          </a:solidFill>
+                          <a:latin typeface="Calibri"/>
+                        </a:rPr>
+                        <a:t>26.2</a:t>
+                      </a:r>
+                    </a:p>
+                  </a:txBody>
+                  <a:tcPr>
+                    <a:solidFill>
+                      <a:srgbClr val="FFFFFF"/>
+                    </a:solidFill>
+                  </a:tcPr>
+                </a:tc>
+              </a:tr>
+              <a:tr h="365760">
+                <a:tc>
+                  <a:txBody>
+                    <a:bodyPr/>
+                    <a:lstStyle/>
+                    <a:p>
+                      <a:r>
+                        <a:rPr sz="1050">
+                          <a:solidFill>
+                            <a:srgbClr val="22262B"/>
+                          </a:solidFill>
+                          <a:latin typeface="Calibri"/>
+                        </a:rPr>
+                        <a:t>VLM: ASOT + local boundary refinement</a:t>
+                      </a:r>
+                    </a:p>
+                  </a:txBody>
+                  <a:tcPr>
+                    <a:solidFill>
+                      <a:srgbClr val="ECEEF1"/>
+                    </a:solidFill>
+                  </a:tcPr>
+                </a:tc>
+                <a:tc>
+                  <a:txBody>
+                    <a:bodyPr/>
+                    <a:lstStyle/>
+                    <a:p>
+                      <a:r>
+                        <a:rPr sz="1050">
+                          <a:solidFill>
+                            <a:srgbClr val="22262B"/>
+                          </a:solidFill>
+                          <a:latin typeface="Calibri"/>
+                        </a:rPr>
+                        <a:t>yes</a:t>
+                      </a:r>
+                    </a:p>
+                  </a:txBody>
+                  <a:tcPr>
+                    <a:solidFill>
+                      <a:srgbClr val="ECEEF1"/>
+                    </a:solidFill>
+                  </a:tcPr>
+                </a:tc>
+                <a:tc>
+                  <a:txBody>
+                    <a:bodyPr/>
+                    <a:lstStyle/>
+                    <a:p>
+                      <a:r>
+                        <a:rPr sz="1050">
+                          <a:solidFill>
+                            <a:srgbClr val="22262B"/>
+                          </a:solidFill>
+                          <a:latin typeface="Calibri"/>
+                        </a:rPr>
+                        <a:t>0.352</a:t>
+                      </a:r>
+                    </a:p>
+                  </a:txBody>
+                  <a:tcPr>
+                    <a:solidFill>
+                      <a:srgbClr val="ECEEF1"/>
+                    </a:solidFill>
+                  </a:tcPr>
+                </a:tc>
+                <a:tc>
+                  <a:txBody>
+                    <a:bodyPr/>
+                    <a:lstStyle/>
+                    <a:p>
+                      <a:r>
+                        <a:rPr sz="1050">
+                          <a:solidFill>
+                            <a:srgbClr val="22262B"/>
+                          </a:solidFill>
+                          <a:latin typeface="Calibri"/>
+                        </a:rPr>
+                        <a:t>23.4</a:t>
+                      </a:r>
+                    </a:p>
+                  </a:txBody>
+                  <a:tcPr>
+                    <a:solidFill>
+                      <a:srgbClr val="ECEEF1"/>
+                    </a:solidFill>
+                  </a:tcPr>
+                </a:tc>
+              </a:tr>
+              <a:tr h="365760">
+                <a:tc>
+                  <a:txBody>
+                    <a:bodyPr/>
+                    <a:lstStyle/>
+                    <a:p>
+                      <a:r>
+                        <a:rPr sz="1050">
+                          <a:solidFill>
+                            <a:srgbClr val="22262B"/>
+                          </a:solidFill>
+                          <a:latin typeface="Calibri"/>
+                        </a:rPr>
+                        <a:t>VLM: ASOT (OT + temporal prior)</a:t>
+                      </a:r>
+                    </a:p>
+                  </a:txBody>
+                  <a:tcPr>
+                    <a:solidFill>
+                      <a:srgbClr val="FFFFFF"/>
+                    </a:solidFill>
+                  </a:tcPr>
+                </a:tc>
+                <a:tc>
+                  <a:txBody>
+                    <a:bodyPr/>
+                    <a:lstStyle/>
+                    <a:p>
+                      <a:r>
+                        <a:rPr sz="1050">
+                          <a:solidFill>
+                            <a:srgbClr val="22262B"/>
+                          </a:solidFill>
+                          <a:latin typeface="Calibri"/>
+                        </a:rPr>
+                        <a:t>yes</a:t>
+                      </a:r>
+                    </a:p>
+                  </a:txBody>
+                  <a:tcPr>
+                    <a:solidFill>
+                      <a:srgbClr val="FFFFFF"/>
+                    </a:solidFill>
+                  </a:tcPr>
+                </a:tc>
+                <a:tc>
+                  <a:txBody>
+                    <a:bodyPr/>
+                    <a:lstStyle/>
+                    <a:p>
+                      <a:r>
+                        <a:rPr sz="1050">
+                          <a:solidFill>
+                            <a:srgbClr val="22262B"/>
+                          </a:solidFill>
+                          <a:latin typeface="Calibri"/>
+                        </a:rPr>
+                        <a:t>0.342</a:t>
+                      </a:r>
+                    </a:p>
+                  </a:txBody>
+                  <a:tcPr>
+                    <a:solidFill>
+                      <a:srgbClr val="FFFFFF"/>
+                    </a:solidFill>
+                  </a:tcPr>
+                </a:tc>
+                <a:tc>
+                  <a:txBody>
+                    <a:bodyPr/>
+                    <a:lstStyle/>
+                    <a:p>
+                      <a:r>
+                        <a:rPr sz="1050">
+                          <a:solidFill>
+                            <a:srgbClr val="22262B"/>
+                          </a:solidFill>
+                          <a:latin typeface="Calibri"/>
+                        </a:rPr>
+                        <a:t>22.9</a:t>
+                      </a:r>
+                    </a:p>
+                  </a:txBody>
+                  <a:tcPr>
+                    <a:solidFill>
+                      <a:srgbClr val="FFFFFF"/>
+                    </a:solidFill>
+                  </a:tcPr>
+                </a:tc>
+              </a:tr>
+              <a:tr h="365760">
+                <a:tc>
+                  <a:txBody>
+                    <a:bodyPr/>
+                    <a:lstStyle/>
+                    <a:p>
+                      <a:r>
+                        <a:rPr sz="1050">
+                          <a:solidFill>
+                            <a:srgbClr val="22262B"/>
+                          </a:solidFill>
+                          <a:latin typeface="Calibri"/>
+                        </a:rPr>
+                        <a:t>Segmentation: ATBA-style classifier + DP loop</a:t>
+                      </a:r>
+                    </a:p>
+                  </a:txBody>
+                  <a:tcPr>
+                    <a:solidFill>
+                      <a:srgbClr val="ECEEF1"/>
+                    </a:solidFill>
+                  </a:tcPr>
+                </a:tc>
+                <a:tc>
+                  <a:txBody>
+                    <a:bodyPr/>
+                    <a:lstStyle/>
+                    <a:p>
+                      <a:r>
+                        <a:rPr sz="1050">
+                          <a:solidFill>
+                            <a:srgbClr val="22262B"/>
+                          </a:solidFill>
+                          <a:latin typeface="Calibri"/>
+                        </a:rPr>
+                        <a:t>yes</a:t>
+                      </a:r>
+                    </a:p>
+                  </a:txBody>
+                  <a:tcPr>
+                    <a:solidFill>
+                      <a:srgbClr val="ECEEF1"/>
+                    </a:solidFill>
+                  </a:tcPr>
+                </a:tc>
+                <a:tc>
+                  <a:txBody>
+                    <a:bodyPr/>
+                    <a:lstStyle/>
+                    <a:p>
+                      <a:r>
+                        <a:rPr sz="1050">
+                          <a:solidFill>
+                            <a:srgbClr val="22262B"/>
+                          </a:solidFill>
+                          <a:latin typeface="Calibri"/>
+                        </a:rPr>
+                        <a:t>0.202</a:t>
+                      </a:r>
+                    </a:p>
+                  </a:txBody>
+                  <a:tcPr>
+                    <a:solidFill>
+                      <a:srgbClr val="ECEEF1"/>
+                    </a:solidFill>
+                  </a:tcPr>
+                </a:tc>
+                <a:tc>
+                  <a:txBody>
+                    <a:bodyPr/>
+                    <a:lstStyle/>
+                    <a:p>
+                      <a:r>
+                        <a:rPr sz="1050">
+                          <a:solidFill>
+                            <a:srgbClr val="22262B"/>
+                          </a:solidFill>
+                          <a:latin typeface="Calibri"/>
+                        </a:rPr>
+                        <a:t>14.0</a:t>
+                      </a:r>
+                    </a:p>
+                  </a:txBody>
+                  <a:tcPr>
+                    <a:solidFill>
+                      <a:srgbClr val="ECEEF1"/>
+                    </a:solidFill>
+                  </a:tcPr>
+                </a:tc>
+              </a:tr>
+              <a:tr h="365760">
+                <a:tc>
+                  <a:txBody>
+                    <a:bodyPr/>
+                    <a:lstStyle/>
+                    <a:p>
+                      <a:r>
+                        <a:rPr sz="1050">
+                          <a:solidFill>
+                            <a:srgbClr val="22262B"/>
+                          </a:solidFill>
+                          <a:latin typeface="Calibri"/>
+                        </a:rPr>
+                        <a:t>VLM: hard DP on similarity</a:t>
+                      </a:r>
+                    </a:p>
+                  </a:txBody>
+                  <a:tcPr>
+                    <a:solidFill>
+                      <a:srgbClr val="FFFFFF"/>
+                    </a:solidFill>
+                  </a:tcPr>
+                </a:tc>
+                <a:tc>
+                  <a:txBody>
+                    <a:bodyPr/>
+                    <a:lstStyle/>
+                    <a:p>
+                      <a:r>
+                        <a:rPr sz="1050">
+                          <a:solidFill>
+                            <a:srgbClr val="22262B"/>
+                          </a:solidFill>
+                          <a:latin typeface="Calibri"/>
+                        </a:rPr>
+                        <a:t>yes</a:t>
+                      </a:r>
+                    </a:p>
+                  </a:txBody>
+                  <a:tcPr>
+                    <a:solidFill>
+                      <a:srgbClr val="FFFFFF"/>
+                    </a:solidFill>
+                  </a:tcPr>
+                </a:tc>
+                <a:tc>
+                  <a:txBody>
+                    <a:bodyPr/>
+                    <a:lstStyle/>
+                    <a:p>
+                      <a:r>
+                        <a:rPr sz="1050">
+                          <a:solidFill>
+                            <a:srgbClr val="22262B"/>
+                          </a:solidFill>
+                          <a:latin typeface="Calibri"/>
+                        </a:rPr>
+                        <a:t>0.199</a:t>
+                      </a:r>
+                    </a:p>
+                  </a:txBody>
+                  <a:tcPr>
+                    <a:solidFill>
+                      <a:srgbClr val="FFFFFF"/>
+                    </a:solidFill>
+                  </a:tcPr>
+                </a:tc>
+                <a:tc>
+                  <a:txBody>
+                    <a:bodyPr/>
+                    <a:lstStyle/>
+                    <a:p>
+                      <a:r>
+                        <a:rPr sz="1050">
+                          <a:solidFill>
+                            <a:srgbClr val="22262B"/>
+                          </a:solidFill>
+                          <a:latin typeface="Calibri"/>
+                        </a:rPr>
+                        <a:t>6.7</a:t>
+                      </a:r>
+                    </a:p>
+                  </a:txBody>
+                  <a:tcPr>
+                    <a:solidFill>
+                      <a:srgbClr val="FFFFFF"/>
+                    </a:solidFill>
+                  </a:tcPr>
+                </a:tc>
+              </a:tr>
+              <a:tr h="365760">
+                <a:tc>
+                  <a:txBody>
+                    <a:bodyPr/>
+                    <a:lstStyle/>
+                    <a:p>
+                      <a:r>
+                        <a:rPr sz="1050">
+                          <a:solidFill>
+                            <a:srgbClr val="22262B"/>
+                          </a:solidFill>
+                          <a:latin typeface="Calibri"/>
+                        </a:rPr>
+                        <a:t>Segmentation: HAL-style (+ recon regulariser)</a:t>
+                      </a:r>
+                    </a:p>
+                  </a:txBody>
+                  <a:tcPr>
+                    <a:solidFill>
+                      <a:srgbClr val="ECEEF1"/>
+                    </a:solidFill>
+                  </a:tcPr>
+                </a:tc>
+                <a:tc>
+                  <a:txBody>
+                    <a:bodyPr/>
+                    <a:lstStyle/>
+                    <a:p>
+                      <a:r>
+                        <a:rPr sz="1050">
+                          <a:solidFill>
+                            <a:srgbClr val="22262B"/>
+                          </a:solidFill>
+                          <a:latin typeface="Calibri"/>
+                        </a:rPr>
+                        <a:t>yes</a:t>
+                      </a:r>
+                    </a:p>
+                  </a:txBody>
+                  <a:tcPr>
+                    <a:solidFill>
+                      <a:srgbClr val="ECEEF1"/>
+                    </a:solidFill>
+                  </a:tcPr>
+                </a:tc>
+                <a:tc>
+                  <a:txBody>
+                    <a:bodyPr/>
+                    <a:lstStyle/>
+                    <a:p>
+                      <a:r>
+                        <a:rPr sz="1050">
+                          <a:solidFill>
+                            <a:srgbClr val="22262B"/>
+                          </a:solidFill>
+                          <a:latin typeface="Calibri"/>
+                        </a:rPr>
+                        <a:t>0.149</a:t>
+                      </a:r>
+                    </a:p>
+                  </a:txBody>
+                  <a:tcPr>
+                    <a:solidFill>
+                      <a:srgbClr val="ECEEF1"/>
+                    </a:solidFill>
+                  </a:tcPr>
+                </a:tc>
+                <a:tc>
+                  <a:txBody>
+                    <a:bodyPr/>
+                    <a:lstStyle/>
+                    <a:p>
+                      <a:r>
+                        <a:rPr sz="1050">
+                          <a:solidFill>
+                            <a:srgbClr val="22262B"/>
+                          </a:solidFill>
+                          <a:latin typeface="Calibri"/>
+                        </a:rPr>
+                        <a:t>9.4</a:t>
+                      </a:r>
+                    </a:p>
+                  </a:txBody>
+                  <a:tcPr>
+                    <a:solidFill>
+                      <a:srgbClr val="ECEEF1"/>
+                    </a:solidFill>
+                  </a:tcPr>
+                </a:tc>
+              </a:tr>
+            </a:tbl>
+          </a:graphicData>
+        </a:graphic>
+      </p:graphicFrame>
     </p:spTree>
   </p:cSld>
   <p:clrMapOvr>
@@ -5569,7 +6108,7 @@
                 </a:solidFill>
                 <a:latin typeface="Calibri"/>
               </a:rPr>
-              <a:t>My workstream — MASRA (M1–M7)</a:t>
+              <a:t>Why — the diagnostic evidence</a:t>
             </a:r>
           </a:p>
           <a:p>
@@ -5580,7 +6119,7 @@
                 </a:solidFill>
                 <a:latin typeface="Calibri"/>
               </a:rPr>
-              <a:t>frozen VLM similarity + MASRA-style language regularisation → alignment → DELTA.  M1 starts tomorrow.</a:t>
+              <a:t>the difficulty is the evidence available, not the choice of algorithm</a:t>
             </a:r>
           </a:p>
         </p:txBody>
@@ -5628,577 +6167,125 @@
           </a:p>
         </p:txBody>
       </p:sp>
-      <p:graphicFrame>
-        <p:nvGraphicFramePr>
-          <p:cNvPr id="4" name="Table 3"/>
-          <p:cNvGraphicFramePr>
-            <a:graphicFrameLocks noGrp="1"/>
-          </p:cNvGraphicFramePr>
+      <p:sp>
+        <p:nvSpPr>
+          <p:cNvPr id="4" name="TextBox 3"/>
+          <p:cNvSpPr txBox="1"/>
           <p:nvPr/>
-        </p:nvGraphicFramePr>
-        <p:xfrm>
-          <a:off x="548640" y="1645920"/>
-          <a:ext cx="11064240" cy="2926080"/>
-        </p:xfrm>
-        <a:graphic>
-          <a:graphicData uri="http://schemas.openxmlformats.org/drawingml/2006/table">
-            <a:tbl>
-              <a:tblPr firstRow="1" bandRow="1">
-                <a:tableStyleId>{5C22544A-7EE6-4342-B048-85BDC9FD1C3A}</a:tableStyleId>
-              </a:tblPr>
-              <a:tblGrid>
-                <a:gridCol w="457200"/>
-                <a:gridCol w="7863840"/>
-                <a:gridCol w="2743200"/>
-              </a:tblGrid>
-              <a:tr h="365760">
-                <a:tc>
-                  <a:txBody>
-                    <a:bodyPr/>
-                    <a:lstStyle/>
-                    <a:p>
-                      <a:r>
-                        <a:rPr sz="1000" b="1">
-                          <a:solidFill>
-                            <a:srgbClr val="FFFFFF"/>
-                          </a:solidFill>
-                          <a:latin typeface="Calibri"/>
-                        </a:rPr>
-                        <a:t>#</a:t>
-                      </a:r>
-                    </a:p>
-                  </a:txBody>
-                  <a:tcPr>
-                    <a:solidFill>
-                      <a:srgbClr val="1F3A5F"/>
-                    </a:solidFill>
-                  </a:tcPr>
-                </a:tc>
-                <a:tc>
-                  <a:txBody>
-                    <a:bodyPr/>
-                    <a:lstStyle/>
-                    <a:p>
-                      <a:r>
-                        <a:rPr sz="1000" b="1">
-                          <a:solidFill>
-                            <a:srgbClr val="FFFFFF"/>
-                          </a:solidFill>
-                          <a:latin typeface="Calibri"/>
-                        </a:rPr>
-                        <a:t>Step</a:t>
-                      </a:r>
-                    </a:p>
-                  </a:txBody>
-                  <a:tcPr>
-                    <a:solidFill>
-                      <a:srgbClr val="1F3A5F"/>
-                    </a:solidFill>
-                  </a:tcPr>
-                </a:tc>
-                <a:tc>
-                  <a:txBody>
-                    <a:bodyPr/>
-                    <a:lstStyle/>
-                    <a:p>
-                      <a:r>
-                        <a:rPr sz="1000" b="1">
-                          <a:solidFill>
-                            <a:srgbClr val="FFFFFF"/>
-                          </a:solidFill>
-                          <a:latin typeface="Calibri"/>
-                        </a:rPr>
-                        <a:t>Output</a:t>
-                      </a:r>
-                    </a:p>
-                  </a:txBody>
-                  <a:tcPr>
-                    <a:solidFill>
-                      <a:srgbClr val="1F3A5F"/>
-                    </a:solidFill>
-                  </a:tcPr>
-                </a:tc>
-              </a:tr>
-              <a:tr h="365760">
-                <a:tc>
-                  <a:txBody>
-                    <a:bodyPr/>
-                    <a:lstStyle/>
-                    <a:p>
-                      <a:r>
-                        <a:rPr sz="900">
-                          <a:solidFill>
-                            <a:srgbClr val="22262B"/>
-                          </a:solidFill>
-                          <a:latin typeface="Calibri"/>
-                        </a:rPr>
-                        <a:t>M1</a:t>
-                      </a:r>
-                    </a:p>
-                  </a:txBody>
-                  <a:tcPr>
-                    <a:solidFill>
-                      <a:srgbClr val="FFFFFF"/>
-                    </a:solidFill>
-                  </a:tcPr>
-                </a:tc>
-                <a:tc>
-                  <a:txBody>
-                    <a:bodyPr/>
-                    <a:lstStyle/>
-                    <a:p>
-                      <a:r>
-                        <a:rPr sz="900">
-                          <a:solidFill>
-                            <a:srgbClr val="22262B"/>
-                          </a:solidFill>
-                          <a:latin typeface="Calibri"/>
-                        </a:rPr>
-                        <a:t>Get the MASRA code + a VTG base model; reproduce on TACoS (cooking benchmark — no 50S video needed yet)</a:t>
-                      </a:r>
-                    </a:p>
-                  </a:txBody>
-                  <a:tcPr>
-                    <a:solidFill>
-                      <a:srgbClr val="FFFFFF"/>
-                    </a:solidFill>
-                  </a:tcPr>
-                </a:tc>
-                <a:tc>
-                  <a:txBody>
-                    <a:bodyPr/>
-                    <a:lstStyle/>
-                    <a:p>
-                      <a:r>
-                        <a:rPr sz="900">
-                          <a:solidFill>
-                            <a:srgbClr val="22262B"/>
-                          </a:solidFill>
-                          <a:latin typeface="Calibri"/>
-                        </a:rPr>
-                        <a:t>understand LRCA / ESTA / DAI</a:t>
-                      </a:r>
-                    </a:p>
-                  </a:txBody>
-                  <a:tcPr>
-                    <a:solidFill>
-                      <a:srgbClr val="FFFFFF"/>
-                    </a:solidFill>
-                  </a:tcPr>
-                </a:tc>
-              </a:tr>
-              <a:tr h="365760">
-                <a:tc>
-                  <a:txBody>
-                    <a:bodyPr/>
-                    <a:lstStyle/>
-                    <a:p>
-                      <a:r>
-                        <a:rPr sz="900">
-                          <a:solidFill>
-                            <a:srgbClr val="22262B"/>
-                          </a:solidFill>
-                          <a:latin typeface="Calibri"/>
-                        </a:rPr>
-                        <a:t>M2</a:t>
-                      </a:r>
-                    </a:p>
-                  </a:txBody>
-                  <a:tcPr>
-                    <a:solidFill>
-                      <a:srgbClr val="ECEEF1"/>
-                    </a:solidFill>
-                  </a:tcPr>
-                </a:tc>
-                <a:tc>
-                  <a:txBody>
-                    <a:bodyPr/>
-                    <a:lstStyle/>
-                    <a:p>
-                      <a:r>
-                        <a:rPr sz="900">
-                          <a:solidFill>
-                            <a:srgbClr val="22262B"/>
-                          </a:solidFill>
-                          <a:latin typeface="Calibri"/>
-                        </a:rPr>
-                        <a:t>Add an internvideo2 backbone to delta.features.backbones; build s(transcript × frame) for 50S</a:t>
-                      </a:r>
-                    </a:p>
-                  </a:txBody>
-                  <a:tcPr>
-                    <a:solidFill>
-                      <a:srgbClr val="ECEEF1"/>
-                    </a:solidFill>
-                  </a:tcPr>
-                </a:tc>
-                <a:tc>
-                  <a:txBody>
-                    <a:bodyPr/>
-                    <a:lstStyle/>
-                    <a:p>
-                      <a:r>
-                        <a:rPr sz="900">
-                          <a:solidFill>
-                            <a:srgbClr val="22262B"/>
-                          </a:solidFill>
-                          <a:latin typeface="Calibri"/>
-                        </a:rPr>
-                        <a:t>s (N×T)   [needs raw video]</a:t>
-                      </a:r>
-                    </a:p>
-                  </a:txBody>
-                  <a:tcPr>
-                    <a:solidFill>
-                      <a:srgbClr val="ECEEF1"/>
-                    </a:solidFill>
-                  </a:tcPr>
-                </a:tc>
-              </a:tr>
-              <a:tr h="365760">
-                <a:tc>
-                  <a:txBody>
-                    <a:bodyPr/>
-                    <a:lstStyle/>
-                    <a:p>
-                      <a:r>
-                        <a:rPr sz="900">
-                          <a:solidFill>
-                            <a:srgbClr val="22262B"/>
-                          </a:solidFill>
-                          <a:latin typeface="Calibri"/>
-                        </a:rPr>
-                        <a:t>M3</a:t>
-                      </a:r>
-                    </a:p>
-                  </a:txBody>
-                  <a:tcPr>
-                    <a:solidFill>
-                      <a:srgbClr val="FFFFFF"/>
-                    </a:solidFill>
-                  </a:tcPr>
-                </a:tc>
-                <a:tc>
-                  <a:txBody>
-                    <a:bodyPr/>
-                    <a:lstStyle/>
-                    <a:p>
-                      <a:r>
-                        <a:rPr sz="900">
-                          <a:solidFill>
-                            <a:srgbClr val="22262B"/>
-                          </a:solidFill>
-                          <a:latin typeface="Calibri"/>
-                        </a:rPr>
-                        <a:t>Adapt LRCA — align a transcript relation-matrix (order structure) with the video similarity matrix</a:t>
-                      </a:r>
-                    </a:p>
-                  </a:txBody>
-                  <a:tcPr>
-                    <a:solidFill>
-                      <a:srgbClr val="FFFFFF"/>
-                    </a:solidFill>
-                  </a:tcPr>
-                </a:tc>
-                <a:tc>
-                  <a:txBody>
-                    <a:bodyPr/>
-                    <a:lstStyle/>
-                    <a:p>
-                      <a:r>
-                        <a:rPr sz="900">
-                          <a:solidFill>
-                            <a:srgbClr val="22262B"/>
-                          </a:solidFill>
-                          <a:latin typeface="Calibri"/>
-                        </a:rPr>
-                        <a:t>language regulariser loss</a:t>
-                      </a:r>
-                    </a:p>
-                  </a:txBody>
-                  <a:tcPr>
-                    <a:solidFill>
-                      <a:srgbClr val="FFFFFF"/>
-                    </a:solidFill>
-                  </a:tcPr>
-                </a:tc>
-              </a:tr>
-              <a:tr h="365760">
-                <a:tc>
-                  <a:txBody>
-                    <a:bodyPr/>
-                    <a:lstStyle/>
-                    <a:p>
-                      <a:r>
-                        <a:rPr sz="900">
-                          <a:solidFill>
-                            <a:srgbClr val="22262B"/>
-                          </a:solidFill>
-                          <a:latin typeface="Calibri"/>
-                        </a:rPr>
-                        <a:t>M4</a:t>
-                      </a:r>
-                    </a:p>
-                  </a:txBody>
-                  <a:tcPr>
-                    <a:solidFill>
-                      <a:srgbClr val="ECEEF1"/>
-                    </a:solidFill>
-                  </a:tcPr>
-                </a:tc>
-                <a:tc>
-                  <a:txBody>
-                    <a:bodyPr/>
-                    <a:lstStyle/>
-                    <a:p>
-                      <a:r>
-                        <a:rPr sz="900">
-                          <a:solidFill>
-                            <a:srgbClr val="22262B"/>
-                          </a:solidFill>
-                          <a:latin typeface="Calibri"/>
-                        </a:rPr>
-                        <a:t>Adapt ESTA — align pooled temporal context with the 17 action-name semantics</a:t>
-                      </a:r>
-                    </a:p>
-                  </a:txBody>
-                  <a:tcPr>
-                    <a:solidFill>
-                      <a:srgbClr val="ECEEF1"/>
-                    </a:solidFill>
-                  </a:tcPr>
-                </a:tc>
-                <a:tc>
-                  <a:txBody>
-                    <a:bodyPr/>
-                    <a:lstStyle/>
-                    <a:p>
-                      <a:r>
-                        <a:rPr sz="900">
-                          <a:solidFill>
-                            <a:srgbClr val="22262B"/>
-                          </a:solidFill>
-                          <a:latin typeface="Calibri"/>
-                        </a:rPr>
-                        <a:t>semantic alignment loss</a:t>
-                      </a:r>
-                    </a:p>
-                  </a:txBody>
-                  <a:tcPr>
-                    <a:solidFill>
-                      <a:srgbClr val="ECEEF1"/>
-                    </a:solidFill>
-                  </a:tcPr>
-                </a:tc>
-              </a:tr>
-              <a:tr h="365760">
-                <a:tc>
-                  <a:txBody>
-                    <a:bodyPr/>
-                    <a:lstStyle/>
-                    <a:p>
-                      <a:r>
-                        <a:rPr sz="900">
-                          <a:solidFill>
-                            <a:srgbClr val="22262B"/>
-                          </a:solidFill>
-                          <a:latin typeface="Calibri"/>
-                        </a:rPr>
-                        <a:t>M5</a:t>
-                      </a:r>
-                    </a:p>
-                  </a:txBody>
-                  <a:tcPr>
-                    <a:solidFill>
-                      <a:srgbClr val="FFFFFF"/>
-                    </a:solidFill>
-                  </a:tcPr>
-                </a:tc>
-                <a:tc>
-                  <a:txBody>
-                    <a:bodyPr/>
-                    <a:lstStyle/>
-                    <a:p>
-                      <a:r>
-                        <a:rPr sz="900">
-                          <a:solidFill>
-                            <a:srgbClr val="22262B"/>
-                          </a:solidFill>
-                          <a:latin typeface="Calibri"/>
-                        </a:rPr>
-                        <a:t>Order-preserving alignment (ASOT / delta.align.ta) reads Y* off the regularised similarity</a:t>
-                      </a:r>
-                    </a:p>
-                  </a:txBody>
-                  <a:tcPr>
-                    <a:solidFill>
-                      <a:srgbClr val="FFFFFF"/>
-                    </a:solidFill>
-                  </a:tcPr>
-                </a:tc>
-                <a:tc>
-                  <a:txBody>
-                    <a:bodyPr/>
-                    <a:lstStyle/>
-                    <a:p>
-                      <a:r>
-                        <a:rPr sz="900">
-                          <a:solidFill>
-                            <a:srgbClr val="22262B"/>
-                          </a:solidFill>
-                          <a:latin typeface="Calibri"/>
-                        </a:rPr>
-                        <a:t>Y*</a:t>
-                      </a:r>
-                    </a:p>
-                  </a:txBody>
-                  <a:tcPr>
-                    <a:solidFill>
-                      <a:srgbClr val="FFFFFF"/>
-                    </a:solidFill>
-                  </a:tcPr>
-                </a:tc>
-              </a:tr>
-              <a:tr h="365760">
-                <a:tc>
-                  <a:txBody>
-                    <a:bodyPr/>
-                    <a:lstStyle/>
-                    <a:p>
-                      <a:r>
-                        <a:rPr sz="900">
-                          <a:solidFill>
-                            <a:srgbClr val="22262B"/>
-                          </a:solidFill>
-                          <a:latin typeface="Calibri"/>
-                        </a:rPr>
-                        <a:t>M6</a:t>
-                      </a:r>
-                    </a:p>
-                  </a:txBody>
-                  <a:tcPr>
-                    <a:solidFill>
-                      <a:srgbClr val="ECEEF1"/>
-                    </a:solidFill>
-                  </a:tcPr>
-                </a:tc>
-                <a:tc>
-                  <a:txBody>
-                    <a:bodyPr/>
-                    <a:lstStyle/>
-                    <a:p>
-                      <a:r>
-                        <a:rPr sz="900">
-                          <a:solidFill>
-                            <a:srgbClr val="22262B"/>
-                          </a:solidFill>
-                          <a:latin typeface="Calibri"/>
-                        </a:rPr>
-                        <a:t>Score Y* vs ATBA-in-DELTA / ASOT-in-DELTA / naive floor — TA metrics</a:t>
-                      </a:r>
-                    </a:p>
-                  </a:txBody>
-                  <a:tcPr>
-                    <a:solidFill>
-                      <a:srgbClr val="ECEEF1"/>
-                    </a:solidFill>
-                  </a:tcPr>
-                </a:tc>
-                <a:tc>
-                  <a:txBody>
-                    <a:bodyPr/>
-                    <a:lstStyle/>
-                    <a:p>
-                      <a:r>
-                        <a:rPr sz="900">
-                          <a:solidFill>
-                            <a:srgbClr val="22262B"/>
-                          </a:solidFill>
-                          <a:latin typeface="Calibri"/>
-                        </a:rPr>
-                        <a:t>does VLM+MASRA beat the baselines?</a:t>
-                      </a:r>
-                    </a:p>
-                  </a:txBody>
-                  <a:tcPr>
-                    <a:solidFill>
-                      <a:srgbClr val="ECEEF1"/>
-                    </a:solidFill>
-                  </a:tcPr>
-                </a:tc>
-              </a:tr>
-              <a:tr h="365760">
-                <a:tc>
-                  <a:txBody>
-                    <a:bodyPr/>
-                    <a:lstStyle/>
-                    <a:p>
-                      <a:r>
-                        <a:rPr sz="900">
-                          <a:solidFill>
-                            <a:srgbClr val="22262B"/>
-                          </a:solidFill>
-                          <a:latin typeface="Calibri"/>
-                        </a:rPr>
-                        <a:t>M7</a:t>
-                      </a:r>
-                    </a:p>
-                  </a:txBody>
-                  <a:tcPr>
-                    <a:solidFill>
-                      <a:srgbClr val="FFFFFF"/>
-                    </a:solidFill>
-                  </a:tcPr>
-                </a:tc>
-                <a:tc>
-                  <a:txBody>
-                    <a:bodyPr/>
-                    <a:lstStyle/>
-                    <a:p>
-                      <a:r>
-                        <a:rPr sz="900">
-                          <a:solidFill>
-                            <a:srgbClr val="22262B"/>
-                          </a:solidFill>
-                          <a:latin typeface="Calibri"/>
-                        </a:rPr>
-                        <a:t>Feed best Y* into DELTA's decoder (CTC/CRF/duration unchanged) → Obs%/Pred% MoC</a:t>
-                      </a:r>
-                    </a:p>
-                  </a:txBody>
-                  <a:tcPr>
-                    <a:solidFill>
-                      <a:srgbClr val="FFFFFF"/>
-                    </a:solidFill>
-                  </a:tcPr>
-                </a:tc>
-                <a:tc>
-                  <a:txBody>
-                    <a:bodyPr/>
-                    <a:lstStyle/>
-                    <a:p>
-                      <a:r>
-                        <a:rPr sz="900">
-                          <a:solidFill>
-                            <a:srgbClr val="22262B"/>
-                          </a:solidFill>
-                          <a:latin typeface="Calibri"/>
-                        </a:rPr>
-                        <a:t>the downstream result</a:t>
-                      </a:r>
-                    </a:p>
-                  </a:txBody>
-                  <a:tcPr>
-                    <a:solidFill>
-                      <a:srgbClr val="FFFFFF"/>
-                    </a:solidFill>
-                  </a:tcPr>
-                </a:tc>
-              </a:tr>
-            </a:tbl>
-          </a:graphicData>
-        </a:graphic>
-      </p:graphicFrame>
+        </p:nvSpPr>
+        <p:spPr>
+          <a:xfrm>
+            <a:off x="640080" y="1600200"/>
+            <a:ext cx="10972800" cy="4937760"/>
+          </a:xfrm>
+          <a:prstGeom prst="rect">
+            <a:avLst/>
+          </a:prstGeom>
+          <a:noFill/>
+        </p:spPr>
+        <p:txBody>
+          <a:bodyPr wrap="square">
+            <a:spAutoFit/>
+          </a:bodyPr>
+          <a:lstStyle/>
+          <a:p>
+            <a:pPr>
+              <a:spcAft>
+                <a:spcPts val="600"/>
+              </a:spcAft>
+            </a:pPr>
+            <a:r>
+              <a:rPr sz="1700" b="0">
+                <a:solidFill>
+                  <a:srgbClr val="22262B"/>
+                </a:solidFill>
+                <a:latin typeface="Calibri"/>
+              </a:rPr>
+              <a:t>▸ Fixed overhead camera:  consecutive frames are 0.94 cosine-similar.  Almost nothing changes visually.</a:t>
+            </a:r>
+          </a:p>
+          <a:p>
+            <a:pPr>
+              <a:spcAft>
+                <a:spcPts val="600"/>
+              </a:spcAft>
+            </a:pPr>
+            <a:r>
+              <a:rPr sz="1700" b="0">
+                <a:solidFill>
+                  <a:srgbClr val="22262B"/>
+                </a:solidFill>
+                <a:latin typeface="Calibri"/>
+              </a:rPr>
+              <a:t>▸ Single-frame semantics are weak:  with the correct action vs the OTHER actions in the same transcript, SigLIP2 picks the right one only 27% of the time.</a:t>
+            </a:r>
+          </a:p>
+          <a:p>
+            <a:pPr lvl="1">
+              <a:spcAft>
+                <a:spcPts val="600"/>
+              </a:spcAft>
+            </a:pPr>
+            <a:r>
+              <a:rPr sz="1500">
+                <a:solidFill>
+                  <a:srgbClr val="5B6470"/>
+                </a:solidFill>
+                <a:latin typeface="Calibri"/>
+              </a:rPr>
+              <a:t>– Beating a *random* action is easy (cut_tomato vs add_dressing → 73%). The hard part is cut_tomato vs cut_cucumber vs cut_cheese — which is exactly what the aligner must do.</a:t>
+            </a:r>
+          </a:p>
+          <a:p>
+            <a:pPr>
+              <a:spcAft>
+                <a:spcPts val="600"/>
+              </a:spcAft>
+            </a:pPr>
+            <a:r>
+              <a:rPr sz="1700" b="0">
+                <a:solidFill>
+                  <a:srgbClr val="22262B"/>
+                </a:solidFill>
+                <a:latin typeface="Calibri"/>
+              </a:rPr>
+              <a:t>▸ Boundary signal is near chance:  frame-similarity at true boundaries scores 0.52 (0.50 = chance); I3D managed 0.67.</a:t>
+            </a:r>
+          </a:p>
+          <a:p>
+            <a:pPr>
+              <a:spcAft>
+                <a:spcPts val="600"/>
+              </a:spcAft>
+            </a:pPr>
+            <a:r>
+              <a:rPr sz="1700" b="0">
+                <a:solidFill>
+                  <a:srgbClr val="22262B"/>
+                </a:solidFill>
+                <a:latin typeface="Calibri"/>
+              </a:rPr>
+              <a:t>▸ The segmentation loop self-confirms:  loss 2.47 → 0.45 while relabelling falls 73% → 8% — the classifier confidently fits its own initial mistakes.</a:t>
+            </a:r>
+          </a:p>
+          <a:p>
+            <a:pPr>
+              <a:spcAft>
+                <a:spcPts val="600"/>
+              </a:spcAft>
+            </a:pPr>
+            <a:r>
+              <a:rPr sz="1700" b="0">
+                <a:solidFill>
+                  <a:srgbClr val="22262B"/>
+                </a:solidFill>
+                <a:latin typeface="Calibri"/>
+              </a:rPr>
+              <a:t>▸ Adaptive sampling skips 85% of frames, but only 32% of true boundaries fall inside a refined zone — driven by the same weak similarity.</a:t>
+            </a:r>
+          </a:p>
+        </p:txBody>
+      </p:sp>
     </p:spTree>
   </p:cSld>
   <p:clrMapOvr>
@@ -6254,7 +6341,7 @@
                 </a:solidFill>
                 <a:latin typeface="Calibri"/>
               </a:rPr>
-              <a:t>The full method — where CVA + MASRA land</a:t>
+              <a:t>What I take from this</a:t>
             </a:r>
           </a:p>
           <a:p>
@@ -6265,7 +6352,7 @@
                 </a:solidFill>
                 <a:latin typeface="Calibri"/>
               </a:rPr>
-              <a:t>InternVideo2 similarity  +  MASRA regulariser  +  CVA aligner  →  DELTA</a:t>
+              <a:t>the case for continuing, with clear eyes about the difficulty</a:t>
             </a:r>
           </a:p>
         </p:txBody>
@@ -6347,7 +6434,7 @@
                 </a:solidFill>
                 <a:latin typeface="Calibri"/>
               </a:rPr>
-              <a:t>▸ s(n,t) = cos( InternVideo2_text(action_n), InternVideo2_video(clip_t) )  — frozen, video-native, no classifier.</a:t>
+              <a:t>▸ The question is not "segmentation vs VLM" — both lose to a baseline that never looks at the video.</a:t>
             </a:r>
           </a:p>
           <a:p>
@@ -6363,7 +6450,7 @@
                 </a:solidFill>
                 <a:latin typeface="Calibri"/>
               </a:rPr>
-              <a:t>▸ + MASRA (Eliz):  LRCA / ESTA training-time losses that shape s toward the transcript's semantic-relational structure; MLLM at train only.</a:t>
+              <a:t>▸ The real question:  what evidence could localise a boundary on this dataset at all?</a:t>
             </a:r>
           </a:p>
           <a:p>
@@ -6379,7 +6466,7 @@
                 </a:solidFill>
                 <a:latin typeface="Calibri"/>
               </a:rPr>
-              <a:t>▸ + CVA:  CTE-style encoder on the VLM features; CBD boundary-contrastive loss on the aligned boundary frames.</a:t>
+              <a:t>▸ Argument for temporal context:  every result so far uses FRAME-level evidence. A fixed camera is precisely the case where single frames should fail and video should help.</a:t>
             </a:r>
           </a:p>
           <a:p>
@@ -6395,7 +6482,7 @@
                 </a:solidFill>
                 <a:latin typeface="Calibri"/>
               </a:rPr>
-              <a:t>▸ Order-preserving alignment on s (ASOT — already in DELTA as --model_type wclot, ~1 line to swap the cost matrix)  →  Y*.</a:t>
+              <a:t>▸ → We have not yet fairly tested the VLM direction.  SigLIP2 encodes single frames; VideoLLaMA3 encodes video.  That test has not been run.</a:t>
             </a:r>
           </a:p>
           <a:p>
@@ -6411,23 +6498,7 @@
                 </a:solidFill>
                 <a:latin typeface="Calibri"/>
               </a:rPr>
-              <a:t>▸ Y*  →  DELTA decoder + CRF + duration head (unchanged)  →  Obs%/Pred% MoC on 50Salads.</a:t>
-            </a:r>
-          </a:p>
-          <a:p>
-            <a:pPr>
-              <a:spcAft>
-                <a:spcPts val="600"/>
-              </a:spcAft>
-            </a:pPr>
-            <a:r>
-              <a:rPr sz="1700" b="0">
-                <a:solidFill>
-                  <a:srgbClr val="22262B"/>
-                </a:solidFill>
-                <a:latin typeface="Calibri"/>
-              </a:rPr>
-              <a:t>▸ Contribution: VLM-direct transcript→frame alignment for weakly-supervised dense anticipation — unaddressed.</a:t>
+              <a:t>▸ Caveat, stated plainly:  the segmentation probe is a compact reimplementation (no boundary detector, minutes of training).  It is evidence about the paradigm, NOT a reproduction of HAL — which never ran 50Salads.</a:t>
             </a:r>
           </a:p>
         </p:txBody>
@@ -6487,7 +6558,7 @@
                 </a:solidFill>
                 <a:latin typeface="Calibri"/>
               </a:rPr>
-              <a:t>Sequencing — two VLM tracks, 50Salads</a:t>
+              <a:t>What is built and tested</a:t>
             </a:r>
           </a:p>
           <a:p>
@@ -6498,7 +6569,7 @@
                 </a:solidFill>
                 <a:latin typeface="Calibri"/>
               </a:rPr>
-              <a:t>both blocked on raw 50Salads video for the 50S runs; TACoS reproduction can start now</a:t>
+              <a:t>67 unit tests pass.  These verify the code is correct on synthetic data — they do NOT show the method works.</a:t>
             </a:r>
           </a:p>
         </p:txBody>
@@ -6556,7 +6627,7 @@
         </p:nvGraphicFramePr>
         <p:xfrm>
           <a:off x="548640" y="1645920"/>
-          <a:ext cx="11064240" cy="2194560"/>
+          <a:ext cx="10515600" cy="2926080"/>
         </p:xfrm>
         <a:graphic>
           <a:graphicData uri="http://schemas.openxmlformats.org/drawingml/2006/table">
@@ -6565,9 +6636,9 @@
                 <a:tableStyleId>{5C22544A-7EE6-4342-B048-85BDC9FD1C3A}</a:tableStyleId>
               </a:tblPr>
               <a:tblGrid>
-                <a:gridCol w="1097280"/>
-                <a:gridCol w="5212080"/>
-                <a:gridCol w="4754880"/>
+                <a:gridCol w="2651760"/>
+                <a:gridCol w="5120640"/>
+                <a:gridCol w="2743200"/>
               </a:tblGrid>
               <a:tr h="365760">
                 <a:tc>
@@ -6582,7 +6653,7 @@
                           </a:solidFill>
                           <a:latin typeface="Calibri"/>
                         </a:rPr>
-                        <a:t>When</a:t>
+                        <a:t>Stage</a:t>
                       </a:r>
                     </a:p>
                   </a:txBody>
@@ -6604,7 +6675,7 @@
                           </a:solidFill>
                           <a:latin typeface="Calibri"/>
                         </a:rPr>
-                        <a:t>MASRA track</a:t>
+                        <a:t>Module</a:t>
                       </a:r>
                     </a:p>
                   </a:txBody>
@@ -6626,7 +6697,7 @@
                           </a:solidFill>
                           <a:latin typeface="Calibri"/>
                         </a:rPr>
-                        <a:t>CVA track</a:t>
+                        <a:t>Status</a:t>
                       </a:r>
                     </a:p>
                   </a:txBody>
@@ -6650,7 +6721,7 @@
                           </a:solidFill>
                           <a:latin typeface="Calibri"/>
                         </a:rPr>
-                        <a:t>Tomorrow</a:t>
+                        <a:t>0  semantic-guided sampling</a:t>
                       </a:r>
                     </a:p>
                   </a:txBody>
@@ -6672,7 +6743,7 @@
                           </a:solidFill>
                           <a:latin typeface="Calibri"/>
                         </a:rPr>
-                        <a:t>M1: get MASRA code; reproduce on TACoS; read LRCA / ESTA / DAI</a:t>
+                        <a:t>delta.features.sampling  (+ extract --adaptive)</a:t>
                       </a:r>
                     </a:p>
                   </a:txBody>
@@ -6694,7 +6765,7 @@
                           </a:solidFill>
                           <a:latin typeface="Calibri"/>
                         </a:rPr>
-                        <a:t>get CVA code; reproduce on QVHighlights / TACoS</a:t>
+                        <a:t>built · 7 tests</a:t>
                       </a:r>
                     </a:p>
                   </a:txBody>
@@ -6718,7 +6789,7 @@
                           </a:solidFill>
                           <a:latin typeface="Calibri"/>
                         </a:rPr>
-                        <a:t>+1–2 wk</a:t>
+                        <a:t>1  clip ↔ action similarity</a:t>
                       </a:r>
                     </a:p>
                   </a:txBody>
@@ -6740,7 +6811,7 @@
                           </a:solidFill>
                           <a:latin typeface="Calibri"/>
                         </a:rPr>
-                        <a:t>M2: internvideo2 backbone; chase raw 50S video; build s once available</a:t>
+                        <a:t>delta.align.similarity / cost</a:t>
                       </a:r>
                     </a:p>
                   </a:txBody>
@@ -6762,7 +6833,7 @@
                           </a:solidFill>
                           <a:latin typeface="Calibri"/>
                         </a:rPr>
-                        <a:t>isolate CTE + CBD as reusable modules</a:t>
+                        <a:t>built</a:t>
                       </a:r>
                     </a:p>
                   </a:txBody>
@@ -6786,7 +6857,7 @@
                           </a:solidFill>
                           <a:latin typeface="Calibri"/>
                         </a:rPr>
-                        <a:t>+2–3 wk</a:t>
+                        <a:t>2  coarse ordered decode</a:t>
                       </a:r>
                     </a:p>
                   </a:txBody>
@@ -6808,7 +6879,7 @@
                           </a:solidFill>
                           <a:latin typeface="Calibri"/>
                         </a:rPr>
-                        <a:t>M3–M4: adapt LRCA / ESTA to the transcript setting</a:t>
+                        <a:t>delta.align.asot  (OT + transcript-order prior)</a:t>
                       </a:r>
                     </a:p>
                   </a:txBody>
@@ -6830,7 +6901,7 @@
                           </a:solidFill>
                           <a:latin typeface="Calibri"/>
                         </a:rPr>
-                        <a:t>CTE / CBD on our VLM features (once s exists)</a:t>
+                        <a:t>built · 8 tests</a:t>
                       </a:r>
                     </a:p>
                   </a:txBody>
@@ -6854,7 +6925,7 @@
                           </a:solidFill>
                           <a:latin typeface="Calibri"/>
                         </a:rPr>
-                        <a:t>+3–4 wk</a:t>
+                        <a:t>3  local boundary search</a:t>
                       </a:r>
                     </a:p>
                   </a:txBody>
@@ -6876,7 +6947,7 @@
                           </a:solidFill>
                           <a:latin typeface="Calibri"/>
                         </a:rPr>
-                        <a:t>M5–M6: order-preserving alignment; score Y* (TA metrics) vs baselines</a:t>
+                        <a:t>delta.align.refine  — the novel piece</a:t>
                       </a:r>
                     </a:p>
                   </a:txBody>
@@ -6898,7 +6969,7 @@
                           </a:solidFill>
                           <a:latin typeface="Calibri"/>
                         </a:rPr>
-                        <a:t>join: CBD on the aligned boundaries</a:t>
+                        <a:t>built · 6 tests</a:t>
                       </a:r>
                     </a:p>
                   </a:txBody>
@@ -6922,7 +6993,7 @@
                           </a:solidFill>
                           <a:latin typeface="Calibri"/>
                         </a:rPr>
-                        <a:t>later</a:t>
+                        <a:t>4  contrastive refinement</a:t>
                       </a:r>
                     </a:p>
                   </a:txBody>
@@ -6944,7 +7015,7 @@
                           </a:solidFill>
                           <a:latin typeface="Calibri"/>
                         </a:rPr>
-                        <a:t>M7: Y* → DELTA decoder → Obs%/Pred% MoC</a:t>
+                        <a:t>delta.align.cbd (PBCR) + masra_torch (LRCA/ESTA)</a:t>
                       </a:r>
                     </a:p>
                   </a:txBody>
@@ -6966,7 +7037,143 @@
                           </a:solidFill>
                           <a:latin typeface="Calibri"/>
                         </a:rPr>
-                        <a:t>ablations; write-up</a:t>
+                        <a:t>built · 15 tests</a:t>
+                      </a:r>
+                    </a:p>
+                  </a:txBody>
+                  <a:tcPr>
+                    <a:solidFill>
+                      <a:srgbClr val="FFFFFF"/>
+                    </a:solidFill>
+                  </a:tcPr>
+                </a:tc>
+              </a:tr>
+              <a:tr h="365760">
+                <a:tc>
+                  <a:txBody>
+                    <a:bodyPr/>
+                    <a:lstStyle/>
+                    <a:p>
+                      <a:r>
+                        <a:rPr sz="950">
+                          <a:solidFill>
+                            <a:srgbClr val="22262B"/>
+                          </a:solidFill>
+                          <a:latin typeface="Calibri"/>
+                        </a:rPr>
+                        <a:t>—  backbone gate</a:t>
+                      </a:r>
+                    </a:p>
+                  </a:txBody>
+                  <a:tcPr>
+                    <a:solidFill>
+                      <a:srgbClr val="ECEEF1"/>
+                    </a:solidFill>
+                  </a:tcPr>
+                </a:tc>
+                <a:tc>
+                  <a:txBody>
+                    <a:bodyPr/>
+                    <a:lstStyle/>
+                    <a:p>
+                      <a:r>
+                        <a:rPr sz="950">
+                          <a:solidFill>
+                            <a:srgbClr val="22262B"/>
+                          </a:solidFill>
+                          <a:latin typeface="Calibri"/>
+                        </a:rPr>
+                        <a:t>scripts/verify_backbone_alignment.py</a:t>
+                      </a:r>
+                    </a:p>
+                  </a:txBody>
+                  <a:tcPr>
+                    <a:solidFill>
+                      <a:srgbClr val="ECEEF1"/>
+                    </a:solidFill>
+                  </a:tcPr>
+                </a:tc>
+                <a:tc>
+                  <a:txBody>
+                    <a:bodyPr/>
+                    <a:lstStyle/>
+                    <a:p>
+                      <a:r>
+                        <a:rPr sz="950">
+                          <a:solidFill>
+                            <a:srgbClr val="22262B"/>
+                          </a:solidFill>
+                          <a:latin typeface="Calibri"/>
+                        </a:rPr>
+                        <a:t>built · catches a weak backbone before GPU spend</a:t>
+                      </a:r>
+                    </a:p>
+                  </a:txBody>
+                  <a:tcPr>
+                    <a:solidFill>
+                      <a:srgbClr val="ECEEF1"/>
+                    </a:solidFill>
+                  </a:tcPr>
+                </a:tc>
+              </a:tr>
+              <a:tr h="365760">
+                <a:tc>
+                  <a:txBody>
+                    <a:bodyPr/>
+                    <a:lstStyle/>
+                    <a:p>
+                      <a:r>
+                        <a:rPr sz="950">
+                          <a:solidFill>
+                            <a:srgbClr val="22262B"/>
+                          </a:solidFill>
+                          <a:latin typeface="Calibri"/>
+                        </a:rPr>
+                        <a:t>—  cluster jobs</a:t>
+                      </a:r>
+                    </a:p>
+                  </a:txBody>
+                  <a:tcPr>
+                    <a:solidFill>
+                      <a:srgbClr val="FFFFFF"/>
+                    </a:solidFill>
+                  </a:tcPr>
+                </a:tc>
+                <a:tc>
+                  <a:txBody>
+                    <a:bodyPr/>
+                    <a:lstStyle/>
+                    <a:p>
+                      <a:r>
+                        <a:rPr sz="950">
+                          <a:solidFill>
+                            <a:srgbClr val="22262B"/>
+                          </a:solidFill>
+                          <a:latin typeface="Calibri"/>
+                        </a:rPr>
+                        <a:t>slurm_extract_videollama3.sh · slurm_delta_baselines.sh</a:t>
+                      </a:r>
+                    </a:p>
+                  </a:txBody>
+                  <a:tcPr>
+                    <a:solidFill>
+                      <a:srgbClr val="FFFFFF"/>
+                    </a:solidFill>
+                  </a:tcPr>
+                </a:tc>
+                <a:tc>
+                  <a:txBody>
+                    <a:bodyPr/>
+                    <a:lstStyle/>
+                    <a:p>
+                      <a:r>
+                        <a:rPr sz="950">
+                          <a:solidFill>
+                            <a:srgbClr val="22262B"/>
+                          </a:solidFill>
+                          <a:latin typeface="Calibri"/>
+                        </a:rPr>
+                        <a:t>ready to submit</a:t>
                       </a:r>
                     </a:p>
                   </a:txBody>
@@ -7047,7 +7254,7 @@
                 </a:solidFill>
                 <a:latin typeface="Calibri"/>
               </a:rPr>
-              <a:t>Internship progress review  ·  pivot: HAL → MASRA (VLM required)</a:t>
+              <a:t>Internship progress review  ·  results + what I need</a:t>
             </a:r>
           </a:p>
         </p:txBody>
@@ -7129,7 +7336,7 @@
                 </a:solidFill>
                 <a:latin typeface="Calibri"/>
               </a:rPr>
-              <a:t>▸ Goal: transcript-only Dense Long-Term Action Anticipation (DLTA); focus = the Temporal Alignment (TA) component, on 50Salads.</a:t>
+              <a:t>▸ Goal: transcript-only Dense Long-Term Action Anticipation; focus = the Temporal Alignment (TA) component, on 50Salads.</a:t>
             </a:r>
           </a:p>
           <a:p>
@@ -7145,7 +7352,7 @@
                 </a:solidFill>
                 <a:latin typeface="Calibri"/>
               </a:rPr>
-              <a:t>▸ Direction confirmed (your guidance): the TA must use a VLM, NOT segmentation the way ATBA/HAL do.</a:t>
+              <a:t>▸ Direction (your guidance): the TA must use a VLM, and weak alignment → refine, not segmentation.</a:t>
             </a:r>
           </a:p>
           <a:p>
@@ -7161,7 +7368,7 @@
                 </a:solidFill>
                 <a:latin typeface="Calibri"/>
               </a:rPr>
-              <a:t>▸ Done: research repo + infrastructure, 50Salads analysis, a VLM-direct aligner prototype (21 tests); deep-read of the DELTA code (received); analysed the CVPR'25/26 VLM-alignment literature (HAL, CVA, MASRA, TAN, StepFormer, OVTAS, MLLM4WTAL).</a:t>
+              <a:t>▸ Built and tested: the full two-stage pipeline — semantic similarity → ordered coarse alignment → local boundary search → contrastive refinement.  67 unit tests.</a:t>
             </a:r>
           </a:p>
           <a:p>
@@ -7177,7 +7384,7 @@
                 </a:solidFill>
                 <a:latin typeface="Calibri"/>
               </a:rPr>
-              <a:t>▸ Workstream split:  MASRA track  ·  CVA track.  Both are VLM video-text alignment.</a:t>
+              <a:t>▸ Measured: every configuration so far lands BELOW a baseline that ignores the video entirely (naive-uniform, MoC 0.366).  Best is 0.352.</a:t>
             </a:r>
           </a:p>
           <a:p>
@@ -7193,7 +7400,7 @@
                 </a:solidFill>
                 <a:latin typeface="Calibri"/>
               </a:rPr>
-              <a:t>– HAL was analysed then dropped — it is ATBA + a regulariser, still segmentation-based.</a:t>
+              <a:t>– That holds for the VLM path AND for a segmentation (ATBA/HAL-style) probe — so it is not a method-choice problem.</a:t>
             </a:r>
           </a:p>
           <a:p>
@@ -7209,7 +7416,7 @@
                 </a:solidFill>
                 <a:latin typeface="Calibri"/>
               </a:rPr>
-              <a:t>▸ Blocker: raw 50Salads video for VLM feature extraction (official host down).</a:t>
+              <a:t>▸ Diagnosis: single-FRAME evidence is too weak on a fixed overhead camera. The VLM direction has not yet been fairly tested — VideoLLaMA3 encodes video, SigLIP2 does not.</a:t>
             </a:r>
           </a:p>
           <a:p>
@@ -7225,7 +7432,7 @@
                 </a:solidFill>
                 <a:latin typeface="Calibri"/>
               </a:rPr>
-              <a:t>▸ Next: start building MASRA + its VLM tomorrow.</a:t>
+              <a:t>▸ Blocker: GPU / cluster access.  Raw 50Salads video is now in hand.</a:t>
             </a:r>
           </a:p>
         </p:txBody>
@@ -7285,7 +7492,7 @@
                 </a:solidFill>
                 <a:latin typeface="Calibri"/>
               </a:rPr>
-              <a:t>Questions for you</a:t>
+              <a:t>What I need from you</a:t>
             </a:r>
           </a:p>
           <a:p>
@@ -7296,7 +7503,7 @@
                 </a:solidFill>
                 <a:latin typeface="Calibri"/>
               </a:rPr>
-              <a:t>to set the next phase</a:t>
+              <a:t>access first, then the direction call</a:t>
             </a:r>
           </a:p>
         </p:txBody>
@@ -7378,7 +7585,39 @@
                 </a:solidFill>
                 <a:latin typeface="Calibri"/>
               </a:rPr>
-              <a:t>▸ Can the group share raw 50Salads video?  (blocks the VLM feature extraction for both of us.)</a:t>
+              <a:t>▸ 1.  GPU / cluster account.  Everything below is blocked on it.</a:t>
+            </a:r>
+          </a:p>
+          <a:p>
+            <a:pPr lvl="1">
+              <a:spcAft>
+                <a:spcPts val="600"/>
+              </a:spcAft>
+            </a:pPr>
+            <a:r>
+              <a:rPr sz="1500">
+                <a:solidFill>
+                  <a:srgbClr val="5B6470"/>
+                </a:solidFill>
+                <a:latin typeface="Calibri"/>
+              </a:rPr>
+              <a:t>– VideoLLaMA3 feature extraction · VideoLLaMA3 captions · the real ATBA / wclot baselines.</a:t>
+            </a:r>
+          </a:p>
+          <a:p>
+            <a:pPr lvl="1">
+              <a:spcAft>
+                <a:spcPts val="600"/>
+              </a:spcAft>
+            </a:pPr>
+            <a:r>
+              <a:rPr sz="1500">
+                <a:solidFill>
+                  <a:srgbClr val="5B6470"/>
+                </a:solidFill>
+                <a:latin typeface="Calibri"/>
+              </a:rPr>
+              <a:t>– Remote access (VPN/SSH) confirmed WHILE I am still on-site — otherwise the four remote weeks are lost.</a:t>
             </a:r>
           </a:p>
           <a:p>
@@ -7394,7 +7633,7 @@
                 </a:solidFill>
                 <a:latin typeface="Calibri"/>
               </a:rPr>
-              <a:t>▸ MASRA uses an MLLM at training to generate captions — for us the transcript is already given. Keep the MLLM (to expand labels into descriptions), or drop it and use LRCA/ESTA with the plain labels?</a:t>
+              <a:t>▸ 2.  A decision:  run VideoLLaMA3 as the fair test of the VLM direction, with real ATBA/HAL in parallel as the baseline row we need anyway — rather than pivoting on the evidence above?</a:t>
             </a:r>
           </a:p>
           <a:p>
@@ -7410,7 +7649,7 @@
                 </a:solidFill>
                 <a:latin typeface="Calibri"/>
               </a:rPr>
-              <a:t>▸ Primary target metric — alignment Y* quality on 50Salads, or downstream DLTA MoC?</a:t>
+              <a:t>▸ 3.  Segments into the VLM — a visual marker on the frames, or a text prompt with the candidate timestamps and the two action names?</a:t>
             </a:r>
           </a:p>
           <a:p>
@@ -7426,7 +7665,7 @@
                 </a:solidFill>
                 <a:latin typeface="Calibri"/>
               </a:rPr>
-              <a:t>▸ Is establishing a 50Salads transcript-only alignment benchmark a contribution?</a:t>
+              <a:t>▸ 4.  Boundary stage — VideoLLaMA3 embeddings + a contrastive objective, or VideoLLaMA3-Chat judging the transition directly?</a:t>
             </a:r>
           </a:p>
           <a:p>
@@ -7442,39 +7681,7 @@
                 </a:solidFill>
                 <a:latin typeface="Calibri"/>
               </a:rPr>
-              <a:t>▸ Frozen VLM only, or is fine-tuning the alignment cost (light adapter) in scope?</a:t>
-            </a:r>
-          </a:p>
-          <a:p>
-            <a:pPr>
-              <a:spcAft>
-                <a:spcPts val="600"/>
-              </a:spcAft>
-            </a:pPr>
-            <a:r>
-              <a:rPr sz="1700" b="0">
-                <a:solidFill>
-                  <a:srgbClr val="22262B"/>
-                </a:solidFill>
-                <a:latin typeface="Calibri"/>
-              </a:rPr>
-              <a:t>▸ VLM backbone — InternVideo2, or something the group already uses?</a:t>
-            </a:r>
-          </a:p>
-          <a:p>
-            <a:pPr>
-              <a:spcAft>
-                <a:spcPts val="600"/>
-              </a:spcAft>
-            </a:pPr>
-            <a:r>
-              <a:rPr sz="1700" b="0">
-                <a:solidFill>
-                  <a:srgbClr val="22262B"/>
-                </a:solidFill>
-                <a:latin typeface="Calibri"/>
-              </a:rPr>
-              <a:t>▸ Do we have the DELTA supplementary material (loss weights, decoder hyperparameters)?</a:t>
+              <a:t>▸ 5.  Which recent paper did you mean by "passes things to a VLM and reasons in real time"? (TOGA fits — weakly-supervised grounding, no timestamps.)</a:t>
             </a:r>
           </a:p>
         </p:txBody>

</xml_diff>

<commit_message>
Reframe the deck around the hybrid method, not the HAL->MASRA pivot
The deck still described the direction as "pivot to MASRA, MASRA track / CVA
track", which the hybrid superseded. Slide 4 now presents the actual pipeline
(semantic front-end -> coarse ordered alignment -> local boundary search ->
contrastive refinement, with optional fallbacks) and states that no single
paper covers weak supervision x VLM x ordered transcript alignment, so each
stage borrows the piece that fits.

Slide 12 replaced with the stage-by-stage source map: OVTAS, HiERO-StepG,
ASOT/CLOT, ours, CVA + MASRA, CLOT/D-CLOT, TOGA/VideoLLaMA3, DELTA.

Also swapped the stale "raw video unavailable" blocker for GPU access.
</commit_message>
<xml_diff>
--- a/slides/DELTA_progress.pptx
+++ b/slides/DELTA_progress.pptx
@@ -3837,7 +3837,7 @@
                           </a:solidFill>
                           <a:latin typeface="Calibri"/>
                         </a:rPr>
-                        <a:t>Eliz — the language regulariser</a:t>
+                        <a:t>Stage B2 — relational training signal</a:t>
                       </a:r>
                     </a:p>
                   </a:txBody>
@@ -4262,7 +4262,7 @@
                 </a:solidFill>
                 <a:latin typeface="Calibri"/>
               </a:rPr>
-              <a:t>Scoping — the workstream split</a:t>
+              <a:t>The hybrid — which paper feeds which stage</a:t>
             </a:r>
           </a:p>
           <a:p>
@@ -4273,7 +4273,7 @@
                 </a:solidFill>
                 <a:latin typeface="Calibri"/>
               </a:rPr>
-              <a:t>MASRA track   ·   CVA track   ·   both VLM</a:t>
+              <a:t>VideoLLaMA3 as the encoder throughout  ·  full table in articles-by-pipeline-part.xlsx</a:t>
             </a:r>
           </a:p>
         </p:txBody>
@@ -4355,17 +4355,7 @@
                 </a:solidFill>
                 <a:latin typeface="Calibri"/>
               </a:rPr>
-              <a:t>▸ Supervisor's direction: the TA must use a VLM; no segmentation-based approach.</a:t>
-            </a:r>
-          </a:p>
-          <a:p>
-            <a:pPr>
-              <a:spcAft>
-                <a:spcPts val="400"/>
-              </a:spcAft>
-            </a:pPr>
-            <a:r>
-              <a:t> </a:t>
+              <a:t>▸ Input:  raw video + ordered transcript, no timestamps  —  DELTA's weak-supervision setup.</a:t>
             </a:r>
           </a:p>
           <a:p>
@@ -4381,7 +4371,7 @@
                 </a:solidFill>
                 <a:latin typeface="Calibri"/>
               </a:rPr>
-              <a:t>▸ CVA track:  build the VLM aligner — CTE encoder + CBD boundary-contrastive loss.</a:t>
+              <a:t>▸ Semantic front-end:  frozen VLM clip↔action similarity  —  OVTAS.</a:t>
             </a:r>
           </a:p>
           <a:p>
@@ -4397,17 +4387,7 @@
                 </a:solidFill>
                 <a:latin typeface="Calibri"/>
               </a:rPr>
-              <a:t>▸ Eliz → MASRA:  the training-time language regulariser — LRCA / ESTA — that shapes the video↔transcript similarity, then an order-preserving alignment reads Y* off it.</a:t>
-            </a:r>
-          </a:p>
-          <a:p>
-            <a:pPr>
-              <a:spcAft>
-                <a:spcPts val="400"/>
-              </a:spcAft>
-            </a:pPr>
-            <a:r>
-              <a:t> </a:t>
+              <a:t>▸ Stage A, coarse alignment:  force actions into transcript order  —  monotonic DP + HiERO-StepG's strict monotonicity; solved with ASOT / CLOT optimal transport.</a:t>
             </a:r>
           </a:p>
           <a:p>
@@ -4423,7 +4403,7 @@
                 </a:solidFill>
                 <a:latin typeface="Calibri"/>
               </a:rPr>
-              <a:t>▸ Structurally: CVA produces the alignment; MASRA (like HAL did on the segmentation side) is an auxiliary training signal that improves it — measured on TA metrics, then downstream MoC.</a:t>
+              <a:t>▸ Stage B1, segment extent:  confident temporal extent around each coarse location  —  HiERO-StepG.</a:t>
             </a:r>
           </a:p>
           <a:p>
@@ -4439,7 +4419,55 @@
                 </a:solidFill>
                 <a:latin typeface="Calibri"/>
               </a:rPr>
-              <a:t>▸ VLM for both: InternVideo2 (video-native) instead of CVA/MASRA's SlowFast + frame-CLIP.</a:t>
+              <a:t>▸ Stage B2, exact transition:  search for the best crossover point  —  OURS, with CVA's boundary-contrastive principle and MASRA's LRCA as the training signal.</a:t>
+            </a:r>
+          </a:p>
+          <a:p>
+            <a:pPr>
+              <a:spcAft>
+                <a:spcPts val="600"/>
+              </a:spcAft>
+            </a:pPr>
+            <a:r>
+              <a:rPr sz="1700" b="0">
+                <a:solidFill>
+                  <a:srgbClr val="22262B"/>
+                </a:solidFill>
+                <a:latin typeface="Calibri"/>
+              </a:rPr>
+              <a:t>▸ Optional C:  frame/segment consistency if boundaries stay noisy  —  CLOT / D-CLOT.</a:t>
+            </a:r>
+          </a:p>
+          <a:p>
+            <a:pPr>
+              <a:spcAft>
+                <a:spcPts val="600"/>
+              </a:spcAft>
+            </a:pPr>
+            <a:r>
+              <a:rPr sz="1700" b="0">
+                <a:solidFill>
+                  <a:srgbClr val="22262B"/>
+                </a:solidFill>
+                <a:latin typeface="Calibri"/>
+              </a:rPr>
+              <a:t>▸ Optional D:  reason only about difficult boundaries  —  TOGA / VideoLLaMA3.</a:t>
+            </a:r>
+          </a:p>
+          <a:p>
+            <a:pPr>
+              <a:spcAft>
+                <a:spcPts val="600"/>
+              </a:spcAft>
+            </a:pPr>
+            <a:r>
+              <a:rPr sz="1700" b="0">
+                <a:solidFill>
+                  <a:srgbClr val="22262B"/>
+                </a:solidFill>
+                <a:latin typeface="Calibri"/>
+              </a:rPr>
+              <a:t>▸ Output:  dense Y* into the unchanged DELTA decoder.</a:t>
             </a:r>
           </a:p>
         </p:txBody>
@@ -4879,7 +4907,7 @@
                           </a:solidFill>
                           <a:latin typeface="Calibri"/>
                         </a:rPr>
-                        <a:t>Raw 50Salads video unavailable</a:t>
+                        <a:t>GPU / cluster access</a:t>
                       </a:r>
                     </a:p>
                   </a:txBody>
@@ -4901,7 +4929,7 @@
                           </a:solidFill>
                           <a:latin typeface="Calibri"/>
                         </a:rPr>
-                        <a:t>blocks VLM feature extraction (the core of both tracks)</a:t>
+                        <a:t>blocks VideoLLaMA3 extraction and the real ATBA / wclot baselines</a:t>
                       </a:r>
                     </a:p>
                   </a:txBody>
@@ -4923,7 +4951,7 @@
                           </a:solidFill>
                           <a:latin typeface="Calibri"/>
                         </a:rPr>
-                        <a:t>chase a lab copy; meanwhile reproduce MASRA/CVA on TACoS (cooking VTG benchmark)</a:t>
+                        <a:t>account + remote access confirmed before the on-site weeks end</a:t>
                       </a:r>
                     </a:p>
                   </a:txBody>
@@ -8090,7 +8118,7 @@
                 </a:solidFill>
                 <a:latin typeface="Calibri"/>
               </a:rPr>
-              <a:t>the TA must use a VLM  ·  CVA + MASRA as the references</a:t>
+              <a:t>weak alignment → refine  ·  a hybrid, stage by stage</a:t>
             </a:r>
           </a:p>
         </p:txBody>
@@ -8188,7 +8216,7 @@
                 </a:solidFill>
                 <a:latin typeface="Calibri"/>
               </a:rPr>
-              <a:t>– frozen I3D  →  trained frame classifier  →  posteriors P  →  boundary/transition scores  →  DP  →  Y*</a:t>
+              <a:t>– frozen I3D  →  trained frame classifier  →  posteriors  →  boundary scores  →  DP  →  Y*</a:t>
             </a:r>
           </a:p>
           <a:p>
@@ -8204,7 +8232,7 @@
                 </a:solidFill>
                 <a:latin typeface="Calibri"/>
               </a:rPr>
-              <a:t>– the alignment can be no better than that classifier — and on 50Salads (fixed camera, near-duplicate cut_* / add_* actions) it is a near-worst case.</a:t>
+              <a:t>– the alignment can be no better than that classifier — and on 50Salads (fixed camera, near-duplicate cut_* / add_* actions) that is close to a worst case.</a:t>
             </a:r>
           </a:p>
           <a:p>
@@ -8220,7 +8248,7 @@
                 </a:solidFill>
                 <a:latin typeface="Calibri"/>
               </a:rPr>
-              <a:t>▸ Our direction — "alignment THROUGH semantic matching":</a:t>
+              <a:t>▸ Our direction — "weak alignment, then refine", built as a HYBRID rather than one paper:</a:t>
             </a:r>
           </a:p>
           <a:p>
@@ -8236,7 +8264,7 @@
                 </a:solidFill>
                 <a:latin typeface="Calibri"/>
               </a:rPr>
-              <a:t>– frozen VLM:  s(n, t) = sim( text(action_n), video_t )  →  order-preserving alignment  →  Y*</a:t>
+              <a:t>– semantic front-end (OVTAS idea)  →  coarse ordered alignment (monotonic DP + HiERO-StepG)  →  local boundary search (ours)  →  contrastive refinement (CVA principle + MASRA LRCA)</a:t>
             </a:r>
           </a:p>
           <a:p>
@@ -8252,7 +8280,7 @@
                 </a:solidFill>
                 <a:latin typeface="Calibri"/>
               </a:rPr>
-              <a:t>– no frame classifier; the fine-grained vocabulary is disambiguated by the noun, from step 0.</a:t>
+              <a:t>– optional fallbacks: CLOT / D-CLOT for noisy boundaries, TOGA / VideoLLaMA3 reasoning for hard ones.</a:t>
             </a:r>
           </a:p>
           <a:p>
@@ -8268,39 +8296,7 @@
                 </a:solidFill>
                 <a:latin typeface="Calibri"/>
               </a:rPr>
-              <a:t>▸ Two CVPR'25/26 papers do exactly this for video temporal grounding, and we adapt them:</a:t>
-            </a:r>
-          </a:p>
-          <a:p>
-            <a:pPr lvl="1">
-              <a:spcAft>
-                <a:spcPts val="600"/>
-              </a:spcAft>
-            </a:pPr>
-            <a:r>
-              <a:rPr sz="1500">
-                <a:solidFill>
-                  <a:srgbClr val="5B6470"/>
-                </a:solidFill>
-                <a:latin typeface="Calibri"/>
-              </a:rPr>
-              <a:t>– CVA (CVPR'26) — the aligner: hierarchical encoder + boundary-contrastive loss.</a:t>
-            </a:r>
-          </a:p>
-          <a:p>
-            <a:pPr lvl="1">
-              <a:spcAft>
-                <a:spcPts val="600"/>
-              </a:spcAft>
-            </a:pPr>
-            <a:r>
-              <a:rPr sz="1500">
-                <a:solidFill>
-                  <a:srgbClr val="5B6470"/>
-                </a:solidFill>
-                <a:latin typeface="Calibri"/>
-              </a:rPr>
-              <a:t>– MASRA (2026) — the language regulariser: align a text relation-matrix to the video similarity matrix; MLLM used at training only, discarded at inference.  (Eliz)</a:t>
+              <a:t>▸ No single paper covers {weak supervision} × {VLM} × {ordered transcript alignment} — each stage borrows the piece that fits, and the boundary search is our own.</a:t>
             </a:r>
           </a:p>
         </p:txBody>

</xml_diff>

<commit_message>
Reframe slide 11 as components borrowed, and state the CVA GT-span limitation
The subtitle implied CVA and MASRA were the method. Retitled, and added the
correction that published CBD anchors on GT-span boundaries, so what we built
is our own PBCR objective rather than a reuse of CVA's loss.
</commit_message>
<xml_diff>
--- a/slides/DELTA_progress.pptx
+++ b/slides/DELTA_progress.pptx
@@ -3997,7 +3997,7 @@
                 </a:solidFill>
                 <a:latin typeface="Calibri"/>
               </a:rPr>
-              <a:t>Progress 6 — the two VLM-alignment references</a:t>
+              <a:t>Progress 6 — two papers we borrow components from</a:t>
             </a:r>
           </a:p>
           <a:p>
@@ -4008,7 +4008,7 @@
                 </a:solidFill>
                 <a:latin typeface="Calibri"/>
               </a:rPr>
-              <a:t>CVA = the aligner   ·   MASRA = the language regulariser</a:t>
+              <a:t>we take principles and rebuild them for the weak setting — the adaptation is ours</a:t>
             </a:r>
           </a:p>
         </p:txBody>
@@ -4090,7 +4090,7 @@
                 </a:solidFill>
                 <a:latin typeface="Calibri"/>
               </a:rPr>
-              <a:t>▸ CVA (CVPR'26) — Context-aware Video-text Alignment.  Task: video temporal grounding (query → span), CLIP+SlowFast, SOTA.  Contribution = the aligner:</a:t>
+              <a:t>▸ CVA (CVPR'26) — Context-aware Video-text Alignment.  Task: video temporal grounding (query → span), CLIP + SlowFast, SOTA, FULLY SUPERVISED:</a:t>
             </a:r>
           </a:p>
           <a:p>
@@ -4106,7 +4106,7 @@
                 </a:solidFill>
                 <a:latin typeface="Calibri"/>
               </a:rPr>
-              <a:t>– CTE hierarchical encoder (windowed self-attn + learnable queries + bidirectional cross-attn)</a:t>
+              <a:t>– CTE hierarchical encoder;  CBD boundary-contrastive loss;  QCD query-aware augmentation.</a:t>
             </a:r>
           </a:p>
           <a:p>
@@ -4122,7 +4122,23 @@
                 </a:solidFill>
                 <a:latin typeface="Calibri"/>
               </a:rPr>
-              <a:t>– CBD boundary-contrastive loss + QCD query-aware augmentation.</a:t>
+              <a:t>– Important: published CBD anchors on GROUND-TRUTH span boundaries and defines its negatives relative to that span.  We cannot use it as-is.</a:t>
+            </a:r>
+          </a:p>
+          <a:p>
+            <a:pPr lvl="1">
+              <a:spcAft>
+                <a:spcPts val="600"/>
+              </a:spcAft>
+            </a:pPr>
+            <a:r>
+              <a:rPr sz="1500">
+                <a:solidFill>
+                  <a:srgbClr val="5B6470"/>
+                </a:solidFill>
+                <a:latin typeface="Calibri"/>
+              </a:rPr>
+              <a:t>– → we keep only the principle — a boundary deserves its own contrastive representation — and rebuild it on our own CONFIDENT pseudo-boundaries.  That is our objective (PBCR), not CVA's.</a:t>
             </a:r>
           </a:p>
           <a:p>
@@ -4138,7 +4154,7 @@
                 </a:solidFill>
                 <a:latin typeface="Calibri"/>
               </a:rPr>
-              <a:t>▸ MASRA (2026) — MLLM-Assisted Semantic-Relational Consistent Alignment.  Same task, CLIP + an MLLM.  Contribution = a training-time language regulariser:</a:t>
+              <a:t>▸ MASRA (2026) — MLLM-Assisted Semantic-Relational Consistent Alignment.  Same task, also fully supervised.  We take the training-time regularisers:</a:t>
             </a:r>
           </a:p>
           <a:p>
@@ -4154,7 +4170,7 @@
                 </a:solidFill>
                 <a:latin typeface="Calibri"/>
               </a:rPr>
-              <a:t>– LRCA — align a text relation-matrix (from MLLM captions) with the video's similarity matrix</a:t>
+              <a:t>– LRCA — align a text relation-matrix with the video's similarity matrix;  ESTA — align pooled temporal context with action semantics.</a:t>
             </a:r>
           </a:p>
           <a:p>
@@ -4170,22 +4186,6 @@
                 </a:solidFill>
                 <a:latin typeface="Calibri"/>
               </a:rPr>
-              <a:t>– ESTA — align pooled temporal context with action/event semantics</a:t>
-            </a:r>
-          </a:p>
-          <a:p>
-            <a:pPr lvl="1">
-              <a:spcAft>
-                <a:spcPts val="600"/>
-              </a:spcAft>
-            </a:pPr>
-            <a:r>
-              <a:rPr sz="1500">
-                <a:solidFill>
-                  <a:srgbClr val="5B6470"/>
-                </a:solidFill>
-                <a:latin typeface="Calibri"/>
-              </a:rPr>
               <a:t>– MLLM used ONLY at training, discarded at inference  (= DELTA's philosophy).</a:t>
             </a:r>
           </a:p>
@@ -4202,7 +4202,7 @@
                 </a:solidFill>
                 <a:latin typeface="Calibri"/>
               </a:rPr>
-              <a:t>▸ Both: grounding, supervised, not procedural — we adapt them to transcript-supervised 50Salads.</a:t>
+              <a:t>▸ Both are grounding tasks and supervised — components, not drop-in methods.</a:t>
             </a:r>
           </a:p>
         </p:txBody>

</xml_diff>